<commit_message>
Update PreRequisite evidently dan Gambar
</commit_message>
<xml_diff>
--- a/BNI Data Analytics Training - Day 20 - MLOps_PreRequisite_Hendrie.pptx
+++ b/BNI Data Analytics Training - Day 20 - MLOps_PreRequisite_Hendrie.pptx
@@ -275,7 +275,7 @@
       <p15:sldGuideLst xmlns:p15="http://schemas.microsoft.com/office/powerpoint/2012/main"/>
     </p:ext>
     <p:ext uri="GoogleSlidesCustomDataVersion2">
-      <go:slidesCustomData xmlns:go="http://customooxmlschemas.google.com/" xmlns:ahyp="http://schemas.microsoft.com/office/drawing/2018/hyperlinkcolor" xmlns:p15="http://schemas.microsoft.com/office/powerpoint/2012/main" xmlns:p14="http://schemas.microsoft.com/office/powerpoint/2010/main" xmlns:com="http://schemas.openxmlformats.org/drawingml/2006/compatibility" xmlns:pvml="urn:schemas-microsoft-com:office:powerpoint" xmlns:v="urn:schemas-microsoft-com:vml" xmlns:o="urn:schemas-microsoft-com:office:office" xmlns:dgm="http://schemas.openxmlformats.org/drawingml/2006/diagram" xmlns:c="http://schemas.openxmlformats.org/drawingml/2006/chart" xmlns:mv="urn:schemas-microsoft-com:mac:vml" xmlns:mc="http://schemas.openxmlformats.org/markup-compatibility/2006" xmlns="" r:id="rId71" roundtripDataSignature="AMtx7mjQstnE3eehK156vzVORhLgrHr8FA=="/>
+      <go:slidesCustomData xmlns="" xmlns:mc="http://schemas.openxmlformats.org/markup-compatibility/2006" xmlns:mv="urn:schemas-microsoft-com:mac:vml" xmlns:c="http://schemas.openxmlformats.org/drawingml/2006/chart" xmlns:dgm="http://schemas.openxmlformats.org/drawingml/2006/diagram" xmlns:o="urn:schemas-microsoft-com:office:office" xmlns:v="urn:schemas-microsoft-com:vml" xmlns:pvml="urn:schemas-microsoft-com:office:powerpoint" xmlns:com="http://schemas.openxmlformats.org/drawingml/2006/compatibility" xmlns:p14="http://schemas.microsoft.com/office/powerpoint/2010/main" xmlns:p15="http://schemas.microsoft.com/office/powerpoint/2012/main" xmlns:ahyp="http://schemas.microsoft.com/office/drawing/2018/hyperlinkcolor" xmlns:go="http://customooxmlschemas.google.com/" r:id="rId71" roundtripDataSignature="AMtx7mjQstnE3eehK156vzVORhLgrHr8FA=="/>
     </p:ext>
   </p:extLst>
 </p:presentation>
@@ -3468,7 +3468,7 @@
           <p:nvPr>
             <p:extLst>
               <p:ext uri="{D42A27DB-BD31-4B8C-83A1-F6EECF244321}">
-                <p14:modId xmlns:p14="http://schemas.microsoft.com/office/powerpoint/2010/main" val="1645694466"/>
+                <p14:modId xmlns:p14="http://schemas.microsoft.com/office/powerpoint/2010/main" val="1614579202"/>
               </p:ext>
             </p:extLst>
           </p:nvPr>
@@ -5112,21 +5112,8 @@
                           <a:ea typeface="Calibri" panose="020F0502020204030204" pitchFamily="34" charset="0"/>
                           <a:cs typeface="Calibri" panose="020F0502020204030204" pitchFamily="34" charset="0"/>
                         </a:rPr>
-                        <a:t>pip install </a:t>
+                        <a:t>pip install evidently</a:t>
                       </a:r>
-                      <a:r>
-                        <a:rPr lang="en-ID" sz="4000" b="1" dirty="0" err="1">
-                          <a:latin typeface="Calibri" panose="020F0502020204030204" pitchFamily="34" charset="0"/>
-                          <a:ea typeface="Calibri" panose="020F0502020204030204" pitchFamily="34" charset="0"/>
-                          <a:cs typeface="Calibri" panose="020F0502020204030204" pitchFamily="34" charset="0"/>
-                        </a:rPr>
-                        <a:t>evidentl</a:t>
-                      </a:r>
-                      <a:endParaRPr lang="en-ID" sz="4000" b="1" dirty="0">
-                        <a:latin typeface="Calibri" panose="020F0502020204030204" pitchFamily="34" charset="0"/>
-                        <a:ea typeface="Calibri" panose="020F0502020204030204" pitchFamily="34" charset="0"/>
-                        <a:cs typeface="Calibri" panose="020F0502020204030204" pitchFamily="34" charset="0"/>
-                      </a:endParaRPr>
                     </a:p>
                   </a:txBody>
                   <a:tcPr anchor="ctr">

</xml_diff>